<commit_message>
docs(presentation): fine-tune final review deck to synchronize with 75-test suite, Max-Product belief DP, and complete IEEE publication package
</commit_message>
<xml_diff>
--- a/Final_Review_Presentation_WSN_Adaptive_Routing.pptx
+++ b/Final_Review_Presentation_WSN_Adaptive_Routing.pptx
@@ -5507,7 +5507,7 @@
               </a:defRPr>
             </a:pPr>
             <a:r>
-              <a:t>Teaching sensor networks to look ahead in time, anticipate solar recharge, and recover from failures on the fly.</a:t>
+              <a:t>Teaching sensor networks to look ahead in time, resolve channel &amp; battery uncertainty, and recover from failures on the fly.</a:t>
             </a:r>
           </a:p>
         </p:txBody>
@@ -5595,7 +5595,7 @@
             </a:r>
             <a:br/>
             <a:r>
-              <a:t>24-Bin Belief Filter &amp; Sim Core</a:t>
+              <a:t>Max-Product Belief DP &amp; Sim Core</a:t>
             </a:r>
           </a:p>
         </p:txBody>
@@ -5683,7 +5683,7 @@
             </a:r>
             <a:br/>
             <a:r>
-              <a:t>FastAPI REST Backend &amp; React 19 UI</a:t>
+              <a:t>FastAPI REST Engine &amp; React 19 UI</a:t>
             </a:r>
           </a:p>
         </p:txBody>
@@ -5767,11 +5767,11 @@
               </a:defRPr>
             </a:pPr>
             <a:r>
-              <a:t>Heinzelman Radio Physics</a:t>
+              <a:t>Log-Normal Fading &amp; Radio Physics</a:t>
             </a:r>
             <a:br/>
             <a:r>
-              <a:t>Solar Harvesting Profiles &amp; Pytest Suite</a:t>
+              <a:t>75-Test Pytest Suite &amp; IEEE Papers</a:t>
             </a:r>
           </a:p>
         </p:txBody>
@@ -5880,7 +5880,7 @@
               </a:defRPr>
             </a:pPr>
             <a:r>
-              <a:t>ALGORITHM 4: BELIEF FILTER</a:t>
+              <a:t>ALGORITHM 4: BELIEF FILTER &amp; MAX-PRODUCT DP</a:t>
             </a:r>
           </a:p>
         </p:txBody>
@@ -5916,7 +5916,7 @@
               </a:defRPr>
             </a:pPr>
             <a:r>
-              <a:t>Algorithm 4: Routing When Battery Reports Are Stale</a:t>
+              <a:t>Algorithm 4: Routing Under Energy &amp; Channel Uncertainty</a:t>
             </a:r>
           </a:p>
         </p:txBody>
@@ -6131,7 +6131,7 @@
                 </a:solidFill>
                 <a:latin typeface="Calibri"/>
               </a:rPr>
-              <a:t>The Telemetry Dilemma: </a:t>
+              <a:t>Joint Uncertainty Factors: </a:t>
             </a:r>
             <a:r>
               <a:rPr sz="1000">
@@ -6140,7 +6140,7 @@
                 </a:solidFill>
                 <a:latin typeface="Calibri"/>
               </a:rPr>
-              <a:t>Sensors cannot broadcast battery telemetry every round. Transmitting the status update itself burns precious battery! The router must make decisions under uncertainty.</a:t>
+              <a:t>Sensors cannot report telemetry continuously. Compounded by initial battery heterogeneity (0.6, staggered 15-85%), ADC voltage noise (sigma=0.003J), and channel fading (sigma=1.5dB), the router must route under partial observability.</a:t>
             </a:r>
           </a:p>
           <a:p>
@@ -6440,7 +6440,7 @@
                 </a:solidFill>
                 <a:latin typeface="Calibri"/>
               </a:rPr>
-              <a:t>Log-Domain Max-Product Confidence Routing: </a:t>
+              <a:t>Log-Domain Max-Product Belief DP: </a:t>
             </a:r>
             <a:r>
               <a:rPr sz="1000">
@@ -6449,7 +6449,7 @@
                 </a:solidFill>
                 <a:latin typeface="Calibri"/>
               </a:rPr>
-              <a:t>Maximizes the mathematical probability that all hops survive:</a:t>
+              <a:t>Maximizes the joint probability that every hop survives: max prod P(E_u &gt;= E_tx) &lt;=&gt; max sum log P(E_u &gt;= E_tx), proven optimal in polynomial time.</a:t>
             </a:r>
           </a:p>
         </p:txBody>
@@ -6631,7 +6631,7 @@
               </a:defRPr>
             </a:pPr>
             <a:r>
-              <a:t>Under the Hood: How We Structured the 4,000+ Lines of Code</a:t>
+              <a:t>Under the Hood: 7,000+ Lines of Production-Grade Code &amp; IEEE Suite</a:t>
             </a:r>
           </a:p>
         </p:txBody>
@@ -6912,7 +6912,7 @@
                         </a:defRPr>
                       </a:pPr>
                       <a:r>
-                        <a:t>network.py, energy_model.py</a:t>
+                        <a:t>dp_lifetime.py, energy_view.py</a:t>
                       </a:r>
                     </a:p>
                   </a:txBody>
@@ -6936,7 +6936,7 @@
                         </a:defRPr>
                       </a:pPr>
                       <a:r>
-                        <a:t>Euclidean graph adjacency, 1st-order radio model (d^2/d^4), Erx penalty</a:t>
+                        <a:t>3D Lookahead DP, Max-Product Belief Filter under fading &amp; noise</a:t>
                       </a:r>
                     </a:p>
                   </a:txBody>
@@ -6960,7 +6960,7 @@
                         </a:defRPr>
                       </a:pPr>
                       <a:r>
-                        <a:t>425 LOC</a:t>
+                        <a:t>1,040 LOC</a:t>
                       </a:r>
                     </a:p>
                   </a:txBody>
@@ -7010,7 +7010,7 @@
                         </a:defRPr>
                       </a:pPr>
                       <a:r>
-                        <a:t>dp_lifetime.py, routing.py</a:t>
+                        <a:t>network.py, energy_model.py</a:t>
                       </a:r>
                     </a:p>
                   </a:txBody>
@@ -7034,7 +7034,7 @@
                         </a:defRPr>
                       </a:pPr>
                       <a:r>
-                        <a:t>3D Lookahead DP (dp[v][h][t]), DSU live detour recovery, Dijkstra</a:t>
+                        <a:t>Heinzelman radio physics, log-normal shadow fading, DSU detours</a:t>
                       </a:r>
                     </a:p>
                   </a:txBody>
@@ -7058,203 +7058,7 @@
                         </a:defRPr>
                       </a:pPr>
                       <a:r>
-                        <a:t>535 LOC</a:t>
-                      </a:r>
-                    </a:p>
-                  </a:txBody>
-                  <a:tcPr>
-                    <a:solidFill>
-                      <a:srgbClr val="F8FAFC"/>
-                    </a:solidFill>
-                  </a:tcPr>
-                </a:tc>
-              </a:tr>
-              <a:tr h="509451">
-                <a:tc>
-                  <a:txBody>
-                    <a:bodyPr/>
-                    <a:lstStyle/>
-                    <a:p>
-                      <a:pPr>
-                        <a:defRPr sz="950">
-                          <a:solidFill>
-                            <a:srgbClr val="1E293B"/>
-                          </a:solidFill>
-                          <a:latin typeface="Consolas"/>
-                        </a:defRPr>
-                      </a:pPr>
-                      <a:r>
-                        <a:t>src/</a:t>
-                      </a:r>
-                    </a:p>
-                  </a:txBody>
-                  <a:tcPr>
-                    <a:solidFill>
-                      <a:srgbClr val="FFFFFF"/>
-                    </a:solidFill>
-                  </a:tcPr>
-                </a:tc>
-                <a:tc>
-                  <a:txBody>
-                    <a:bodyPr/>
-                    <a:lstStyle/>
-                    <a:p>
-                      <a:pPr>
-                        <a:defRPr sz="950">
-                          <a:solidFill>
-                            <a:srgbClr val="1E293B"/>
-                          </a:solidFill>
-                          <a:latin typeface="Consolas"/>
-                        </a:defRPr>
-                      </a:pPr>
-                      <a:r>
-                        <a:t>clustering.py, energy_view.py</a:t>
-                      </a:r>
-                    </a:p>
-                  </a:txBody>
-                  <a:tcPr>
-                    <a:solidFill>
-                      <a:srgbClr val="FFFFFF"/>
-                    </a:solidFill>
-                  </a:tcPr>
-                </a:tc>
-                <a:tc>
-                  <a:txBody>
-                    <a:bodyPr/>
-                    <a:lstStyle/>
-                    <a:p>
-                      <a:pPr>
-                        <a:defRPr sz="950">
-                          <a:solidFill>
-                            <a:srgbClr val="1E293B"/>
-                          </a:solidFill>
-                          <a:latin typeface="Calibri"/>
-                        </a:defRPr>
-                      </a:pPr>
-                      <a:r>
-                        <a:t>EH-LEACH solar threshold rotation, 24-bin histogram belief filter</a:t>
-                      </a:r>
-                    </a:p>
-                  </a:txBody>
-                  <a:tcPr>
-                    <a:solidFill>
-                      <a:srgbClr val="FFFFFF"/>
-                    </a:solidFill>
-                  </a:tcPr>
-                </a:tc>
-                <a:tc>
-                  <a:txBody>
-                    <a:bodyPr/>
-                    <a:lstStyle/>
-                    <a:p>
-                      <a:pPr algn="r">
-                        <a:defRPr sz="950">
-                          <a:solidFill>
-                            <a:srgbClr val="1E293B"/>
-                          </a:solidFill>
-                          <a:latin typeface="Consolas"/>
-                        </a:defRPr>
-                      </a:pPr>
-                      <a:r>
-                        <a:t>445 LOC</a:t>
-                      </a:r>
-                    </a:p>
-                  </a:txBody>
-                  <a:tcPr>
-                    <a:solidFill>
-                      <a:srgbClr val="FFFFFF"/>
-                    </a:solidFill>
-                  </a:tcPr>
-                </a:tc>
-              </a:tr>
-              <a:tr h="509451">
-                <a:tc>
-                  <a:txBody>
-                    <a:bodyPr/>
-                    <a:lstStyle/>
-                    <a:p>
-                      <a:pPr>
-                        <a:defRPr sz="950">
-                          <a:solidFill>
-                            <a:srgbClr val="1E293B"/>
-                          </a:solidFill>
-                          <a:latin typeface="Consolas"/>
-                        </a:defRPr>
-                      </a:pPr>
-                      <a:r>
-                        <a:t>src/</a:t>
-                      </a:r>
-                    </a:p>
-                  </a:txBody>
-                  <a:tcPr>
-                    <a:solidFill>
-                      <a:srgbClr val="F8FAFC"/>
-                    </a:solidFill>
-                  </a:tcPr>
-                </a:tc>
-                <a:tc>
-                  <a:txBody>
-                    <a:bodyPr/>
-                    <a:lstStyle/>
-                    <a:p>
-                      <a:pPr>
-                        <a:defRPr sz="950">
-                          <a:solidFill>
-                            <a:srgbClr val="1E293B"/>
-                          </a:solidFill>
-                          <a:latin typeface="Consolas"/>
-                        </a:defRPr>
-                      </a:pPr>
-                      <a:r>
-                        <a:t>harvesting_model.py, simulator.py</a:t>
-                      </a:r>
-                    </a:p>
-                  </a:txBody>
-                  <a:tcPr>
-                    <a:solidFill>
-                      <a:srgbClr val="F8FAFC"/>
-                    </a:solidFill>
-                  </a:tcPr>
-                </a:tc>
-                <a:tc>
-                  <a:txBody>
-                    <a:bodyPr/>
-                    <a:lstStyle/>
-                    <a:p>
-                      <a:pPr>
-                        <a:defRPr sz="950">
-                          <a:solidFill>
-                            <a:srgbClr val="1E293B"/>
-                          </a:solidFill>
-                          <a:latin typeface="Calibri"/>
-                        </a:defRPr>
-                      </a:pPr>
-                      <a:r>
-                        <a:t>Diurnal solar, canopy shadows, Poisson bursts, discrete-round loop</a:t>
-                      </a:r>
-                    </a:p>
-                  </a:txBody>
-                  <a:tcPr>
-                    <a:solidFill>
-                      <a:srgbClr val="F8FAFC"/>
-                    </a:solidFill>
-                  </a:tcPr>
-                </a:tc>
-                <a:tc>
-                  <a:txBody>
-                    <a:bodyPr/>
-                    <a:lstStyle/>
-                    <a:p>
-                      <a:pPr algn="r">
-                        <a:defRPr sz="950">
-                          <a:solidFill>
-                            <a:srgbClr val="1E293B"/>
-                          </a:solidFill>
-                          <a:latin typeface="Consolas"/>
-                        </a:defRPr>
-                      </a:pPr>
-                      <a:r>
-                        <a:t>585 LOC</a:t>
+                        <a:t>980 LOC</a:t>
                       </a:r>
                     </a:p>
                   </a:txBody>
@@ -7328,7 +7132,7 @@
                         </a:defRPr>
                       </a:pPr>
                       <a:r>
-                        <a:t>FastAPI REST API, async threadpool execution, SQLite run history</a:t>
+                        <a:t>FastAPI REST API, async threadpool engine, SQLite telemetry store</a:t>
                       </a:r>
                     </a:p>
                   </a:txBody>
@@ -7352,7 +7156,7 @@
                         </a:defRPr>
                       </a:pPr>
                       <a:r>
-                        <a:t>290 LOC</a:t>
+                        <a:t>480 LOC</a:t>
                       </a:r>
                     </a:p>
                   </a:txBody>
@@ -7363,7 +7167,7 @@
                   </a:tcPr>
                 </a:tc>
               </a:tr>
-              <a:tr h="509454">
+              <a:tr h="509451">
                 <a:tc>
                   <a:txBody>
                     <a:bodyPr/>
@@ -7402,7 +7206,7 @@
                         </a:defRPr>
                       </a:pPr>
                       <a:r>
-                        <a:t>src/ (React 19 + TypeScript)</a:t>
+                        <a:t>NetworkTopologyView.tsx, etc.</a:t>
                       </a:r>
                     </a:p>
                   </a:txBody>
@@ -7426,7 +7230,7 @@
                         </a:defRPr>
                       </a:pPr>
                       <a:r>
-                        <a:t>Interactive SVG canvas, timeline scrubber, spatial heatmap, Recharts</a:t>
+                        <a:t>React 19, 7-tier continuous energy gradient, on-node %, inspector card</a:t>
                       </a:r>
                     </a:p>
                   </a:txBody>
@@ -7450,7 +7254,203 @@
                         </a:defRPr>
                       </a:pPr>
                       <a:r>
-                        <a:t>~1,850 LOC</a:t>
+                        <a:t>~2,250 LOC</a:t>
+                      </a:r>
+                    </a:p>
+                  </a:txBody>
+                  <a:tcPr>
+                    <a:solidFill>
+                      <a:srgbClr val="F8FAFC"/>
+                    </a:solidFill>
+                  </a:tcPr>
+                </a:tc>
+              </a:tr>
+              <a:tr h="509451">
+                <a:tc>
+                  <a:txBody>
+                    <a:bodyPr/>
+                    <a:lstStyle/>
+                    <a:p>
+                      <a:pPr>
+                        <a:defRPr sz="950">
+                          <a:solidFill>
+                            <a:srgbClr val="1E293B"/>
+                          </a:solidFill>
+                          <a:latin typeface="Consolas"/>
+                        </a:defRPr>
+                      </a:pPr>
+                      <a:r>
+                        <a:t>tests/</a:t>
+                      </a:r>
+                    </a:p>
+                  </a:txBody>
+                  <a:tcPr>
+                    <a:solidFill>
+                      <a:srgbClr val="FFFFFF"/>
+                    </a:solidFill>
+                  </a:tcPr>
+                </a:tc>
+                <a:tc>
+                  <a:txBody>
+                    <a:bodyPr/>
+                    <a:lstStyle/>
+                    <a:p>
+                      <a:pPr>
+                        <a:defRPr sz="950">
+                          <a:solidFill>
+                            <a:srgbClr val="1E293B"/>
+                          </a:solidFill>
+                          <a:latin typeface="Consolas"/>
+                        </a:defRPr>
+                      </a:pPr>
+                      <a:r>
+                        <a:t>19 automated test modules</a:t>
+                      </a:r>
+                    </a:p>
+                  </a:txBody>
+                  <a:tcPr>
+                    <a:solidFill>
+                      <a:srgbClr val="FFFFFF"/>
+                    </a:solidFill>
+                  </a:tcPr>
+                </a:tc>
+                <a:tc>
+                  <a:txBody>
+                    <a:bodyPr/>
+                    <a:lstStyle/>
+                    <a:p>
+                      <a:pPr>
+                        <a:defRPr sz="950">
+                          <a:solidFill>
+                            <a:srgbClr val="1E293B"/>
+                          </a:solidFill>
+                          <a:latin typeface="Calibri"/>
+                        </a:defRPr>
+                      </a:pPr>
+                      <a:r>
+                        <a:t>75 unit tests (fading, belief DP, DSU speedup, counterexample, API)</a:t>
+                      </a:r>
+                    </a:p>
+                  </a:txBody>
+                  <a:tcPr>
+                    <a:solidFill>
+                      <a:srgbClr val="FFFFFF"/>
+                    </a:solidFill>
+                  </a:tcPr>
+                </a:tc>
+                <a:tc>
+                  <a:txBody>
+                    <a:bodyPr/>
+                    <a:lstStyle/>
+                    <a:p>
+                      <a:pPr algn="r">
+                        <a:defRPr sz="950">
+                          <a:solidFill>
+                            <a:srgbClr val="1E293B"/>
+                          </a:solidFill>
+                          <a:latin typeface="Consolas"/>
+                        </a:defRPr>
+                      </a:pPr>
+                      <a:r>
+                        <a:t>1,450 LOC</a:t>
+                      </a:r>
+                    </a:p>
+                  </a:txBody>
+                  <a:tcPr>
+                    <a:solidFill>
+                      <a:srgbClr val="FFFFFF"/>
+                    </a:solidFill>
+                  </a:tcPr>
+                </a:tc>
+              </a:tr>
+              <a:tr h="509454">
+                <a:tc>
+                  <a:txBody>
+                    <a:bodyPr/>
+                    <a:lstStyle/>
+                    <a:p>
+                      <a:pPr>
+                        <a:defRPr sz="950">
+                          <a:solidFill>
+                            <a:srgbClr val="1E293B"/>
+                          </a:solidFill>
+                          <a:latin typeface="Consolas"/>
+                        </a:defRPr>
+                      </a:pPr>
+                      <a:r>
+                        <a:t>report/</a:t>
+                      </a:r>
+                    </a:p>
+                  </a:txBody>
+                  <a:tcPr>
+                    <a:solidFill>
+                      <a:srgbClr val="F8FAFC"/>
+                    </a:solidFill>
+                  </a:tcPr>
+                </a:tc>
+                <a:tc>
+                  <a:txBody>
+                    <a:bodyPr/>
+                    <a:lstStyle/>
+                    <a:p>
+                      <a:pPr>
+                        <a:defRPr sz="950">
+                          <a:solidFill>
+                            <a:srgbClr val="1E293B"/>
+                          </a:solidFill>
+                          <a:latin typeface="Consolas"/>
+                        </a:defRPr>
+                      </a:pPr>
+                      <a:r>
+                        <a:t>IEEE Papers &amp; 65-page Report</a:t>
+                      </a:r>
+                    </a:p>
+                  </a:txBody>
+                  <a:tcPr>
+                    <a:solidFill>
+                      <a:srgbClr val="F8FAFC"/>
+                    </a:solidFill>
+                  </a:tcPr>
+                </a:tc>
+                <a:tc>
+                  <a:txBody>
+                    <a:bodyPr/>
+                    <a:lstStyle/>
+                    <a:p>
+                      <a:pPr>
+                        <a:defRPr sz="950">
+                          <a:solidFill>
+                            <a:srgbClr val="1E293B"/>
+                          </a:solidFill>
+                          <a:latin typeface="Calibri"/>
+                        </a:defRPr>
+                      </a:pPr>
+                      <a:r>
+                        <a:t>Master Paper, Double-Blind Conference, Digital Twin, Final Report</a:t>
+                      </a:r>
+                    </a:p>
+                  </a:txBody>
+                  <a:tcPr>
+                    <a:solidFill>
+                      <a:srgbClr val="F8FAFC"/>
+                    </a:solidFill>
+                  </a:tcPr>
+                </a:tc>
+                <a:tc>
+                  <a:txBody>
+                    <a:bodyPr/>
+                    <a:lstStyle/>
+                    <a:p>
+                      <a:pPr algn="r">
+                        <a:defRPr sz="950">
+                          <a:solidFill>
+                            <a:srgbClr val="1E293B"/>
+                          </a:solidFill>
+                          <a:latin typeface="Consolas"/>
+                        </a:defRPr>
+                      </a:pPr>
+                      <a:r>
+                        <a:t>3,200 LOC</a:t>
                       </a:r>
                     </a:p>
                   </a:txBody>
@@ -8304,7 +8304,7 @@
               </a:defRPr>
             </a:pPr>
             <a:r>
-              <a:t>The Web Dashboard: Watching Sensor Routes Adapt Live</a:t>
+              <a:t>The Web Dashboard: Individualized Sensor State &amp; Digital Twin</a:t>
             </a:r>
           </a:p>
         </p:txBody>
@@ -8564,7 +8564,7 @@
                 </a:solidFill>
                 <a:latin typeface="Calibri"/>
               </a:rPr>
-              <a:t>Real-Time SVG Canvas: </a:t>
+              <a:t>Continuous 7-Tier Energy Gradient: </a:t>
             </a:r>
             <a:r>
               <a:rPr sz="950">
@@ -8573,7 +8573,7 @@
                 </a:solidFill>
                 <a:latin typeface="Calibri"/>
               </a:rPr>
-              <a:t>Renders all 50 sensor nodes with color-coded operational states: Green (solar rich), Amber (draining relay), Red (browned out).</a:t>
+              <a:t>Visualizes exact charge levels via 7-tier continuous colors (Green 85-100%, Teal 70-85%, Cyan 50-70%, Lime 35-50%, Amber 20-35%, Orange 8-20%, Red &lt;8%) + circular progress meters.</a:t>
             </a:r>
           </a:p>
           <a:p>
@@ -8589,7 +8589,7 @@
                 </a:solidFill>
                 <a:latin typeface="Calibri"/>
               </a:rPr>
-              <a:t>Dynamic Routing Vectors: </a:t>
+              <a:t>On-Node Badges &amp; Click-to-Pin Inspector: </a:t>
             </a:r>
             <a:r>
               <a:rPr sz="950">
@@ -8598,7 +8598,7 @@
                 </a:solidFill>
                 <a:latin typeface="Calibri"/>
               </a:rPr>
-              <a:t>Renders active forwarding paths and cluster head uplinks as directed vector arrows terminating at central Base Station (50, 50).</a:t>
+              <a:t>Displays numerical charge % badges, sun/shade icons (☀/☁), and click-to-pin inspector card comparing Ground Truth E_i vs Belief Mean mu_i +/- sigma vs Divergence Delta E.</a:t>
             </a:r>
           </a:p>
         </p:txBody>
@@ -9446,7 +9446,7 @@
               </a:defRPr>
             </a:pPr>
             <a:r>
-              <a:t>Putting It to the Test: 68 Automated Tests, 100% Pass Rate</a:t>
+              <a:t>Putting It to the Test: 75 Automated Tests, 100% Pass Rate</a:t>
             </a:r>
           </a:p>
         </p:txBody>
@@ -9667,69 +9667,89 @@
             </a:r>
             <a:br/>
             <a:r>
-              <a:t>collected 68 items</a:t>
+              <a:t>collected 75 items</a:t>
             </a:r>
             <a:br/>
             <a:br/>
             <a:r>
-              <a:t>tests/test_adversarial_counterexample.py ....                            [  5%]</a:t>
+              <a:t>tests/test_adversarial_counterexample.py .                               [  1%]</a:t>
             </a:r>
             <a:br/>
             <a:r>
-              <a:t>tests/test_backend_api.py .........                                      [ 19%]</a:t>
+              <a:t>tests/test_backend_api.py ..........                                     [ 14%]</a:t>
             </a:r>
             <a:br/>
             <a:r>
-              <a:t>tests/test_brownout_and_failure.py .....                                 [ 26%]</a:t>
+              <a:t>tests/test_battery_heterogeneity_and_fading.py .......                   [ 24%]</a:t>
             </a:r>
             <a:br/>
             <a:r>
-              <a:t>tests/test_clustering.py .....                                           [ 33%]</a:t>
+              <a:t>tests/test_brownout_and_failure.py ....                                  [ 29%]</a:t>
             </a:r>
             <a:br/>
             <a:r>
-              <a:t>tests/test_dp_lifetime.py ........                                       [ 45%]</a:t>
+              <a:t>tests/test_clustering.py ....                                            [ 34%]</a:t>
             </a:r>
             <a:br/>
             <a:r>
-              <a:t>tests/test_dsu_speedup.py ...                                            [ 50%]</a:t>
+              <a:t>tests/test_dp_lifetime.py .....                                          [ 41%]</a:t>
             </a:r>
             <a:br/>
             <a:r>
-              <a:t>tests/test_energy_aware_dijkstra.py ....                                 [ 55%]</a:t>
+              <a:t>tests/test_dsu_speedup.py .                                              [ 42%]</a:t>
             </a:r>
             <a:br/>
             <a:r>
-              <a:t>tests/test_energy_model.py ......                                        [ 64%]</a:t>
+              <a:t>tests/test_energy_aware_dijkstra.py .                                    [ 44%]</a:t>
             </a:r>
             <a:br/>
             <a:r>
-              <a:t>tests/test_energy_view.py ......                                         [ 73%]</a:t>
+              <a:t>tests/test_energy_model.py ....                                          [ 49%]</a:t>
             </a:r>
             <a:br/>
             <a:r>
-              <a:t>tests/test_harvesting_clustering.py ....                                 [ 79%]</a:t>
+              <a:t>tests/test_energy_view.py .....                                          [ 56%]</a:t>
             </a:r>
             <a:br/>
             <a:r>
-              <a:t>tests/test_harvesting_model.py .....                                     [ 86%]</a:t>
+              <a:t>tests/test_harvesting_clustering.py ..                                   [ 58%]</a:t>
             </a:r>
             <a:br/>
             <a:r>
-              <a:t>tests/test_heterogeneous_harvesting.py ...                               [ 91%]</a:t>
+              <a:t>tests/test_harvesting_model.py ......                                    [ 66%]</a:t>
             </a:r>
             <a:br/>
             <a:r>
-              <a:t>tests/test_network.py ....                                               [ 97%]</a:t>
+              <a:t>tests/test_heterogeneous_harvesting.py ..                                [ 69%]</a:t>
             </a:r>
             <a:br/>
             <a:r>
-              <a:t>tests/test_routing.py ..                                                 [100%]</a:t>
+              <a:t>tests/test_literature_baselines.py ..                                    [ 72%]</a:t>
+            </a:r>
+            <a:br/>
+            <a:r>
+              <a:t>tests/test_network.py .....                                              [ 78%]</a:t>
+            </a:r>
+            <a:br/>
+            <a:r>
+              <a:t>tests/test_rip_up_reroute.py ....                                        [ 84%]</a:t>
+            </a:r>
+            <a:br/>
+            <a:r>
+              <a:t>tests/test_routing.py .                                                  [ 85%]</a:t>
+            </a:r>
+            <a:br/>
+            <a:r>
+              <a:t>tests/test_time_augmented_dp.py ....                                     [ 90%]</a:t>
+            </a:r>
+            <a:br/>
+            <a:r>
+              <a:t>tests/test_uncertainty_routing_and_calibration.py .......                [100%]</a:t>
             </a:r>
             <a:br/>
             <a:br/>
             <a:r>
-              <a:t>============================== 68 passed in 4.72s ==============================</a:t>
+              <a:t>======================= 75 passed, 1 warning in 3.28s ========================</a:t>
             </a:r>
           </a:p>
         </p:txBody>
@@ -9823,7 +9843,7 @@
               </a:spcAft>
             </a:pPr>
             <a:r>
-              <a:rPr sz="1000" b="1">
+              <a:rPr sz="950" b="1">
                 <a:solidFill>
                   <a:srgbClr val="0F172A"/>
                 </a:solidFill>
@@ -9832,13 +9852,13 @@
               <a:t>Mathematical Correctness: </a:t>
             </a:r>
             <a:r>
-              <a:rPr sz="1000">
+              <a:rPr sz="950">
                 <a:solidFill>
                   <a:srgbClr val="0F172A"/>
                 </a:solidFill>
                 <a:latin typeface="Calibri"/>
               </a:rPr>
-              <a:t>test_adversarial_counterexample mathematically confirms Time-DP picks recharging relay B (0.040J) over Dijkstra relay A (0.030J).</a:t>
+              <a:t>test_adversarial_counterexample confirms Time-DP routes through recharging relay B (0.040J) over greedy Dijkstra relay A (0.030J).</a:t>
             </a:r>
           </a:p>
           <a:p>
@@ -9848,7 +9868,7 @@
               </a:spcAft>
             </a:pPr>
             <a:r>
-              <a:rPr sz="1000" b="1">
+              <a:rPr sz="950" b="1">
                 <a:solidFill>
                   <a:srgbClr val="0F172A"/>
                 </a:solidFill>
@@ -9857,7 +9877,7 @@
               <a:t>Radio Physics Compliance: </a:t>
             </a:r>
             <a:r>
-              <a:rPr sz="1000">
+              <a:rPr sz="950">
                 <a:solidFill>
                   <a:srgbClr val="0F172A"/>
                 </a:solidFill>
@@ -9873,22 +9893,22 @@
               </a:spcAft>
             </a:pPr>
             <a:r>
-              <a:rPr sz="1000" b="1">
+              <a:rPr sz="950" b="1">
                 <a:solidFill>
                   <a:srgbClr val="0F172A"/>
                 </a:solidFill>
                 <a:latin typeface="Calibri"/>
               </a:rPr>
-              <a:t>Live Fault Tolerance: </a:t>
-            </a:r>
-            <a:r>
-              <a:rPr sz="1000">
+              <a:t>Channel Fading &amp; Retries: </a:t>
+            </a:r>
+            <a:r>
+              <a:rPr sz="950">
                 <a:solidFill>
                   <a:srgbClr val="0F172A"/>
                 </a:solidFill>
                 <a:latin typeface="Calibri"/>
               </a:rPr>
-              <a:t>test_brownout_and_failure confirms 100% PDR under 10% to 30% injected node deaths via DSU bridge repairs.</a:t>
+              <a:t>test_battery_heterogeneity_and_fading (7 tests) validates log-normal shadow fading (sigma=1.5dB), MAC retries (M=1), and battery heterogeneity.</a:t>
             </a:r>
           </a:p>
           <a:p>
@@ -9898,22 +9918,22 @@
               </a:spcAft>
             </a:pPr>
             <a:r>
-              <a:rPr sz="1000" b="1">
+              <a:rPr sz="950" b="1">
                 <a:solidFill>
                   <a:srgbClr val="0F172A"/>
                 </a:solidFill>
                 <a:latin typeface="Calibri"/>
               </a:rPr>
-              <a:t>Speedup Verification: </a:t>
-            </a:r>
-            <a:r>
-              <a:rPr sz="1000">
+              <a:t>Belief DP &amp; Calibration: </a:t>
+            </a:r>
+            <a:r>
+              <a:rPr sz="950">
                 <a:solidFill>
                   <a:srgbClr val="0F172A"/>
                 </a:solidFill>
                 <a:latin typeface="Calibri"/>
               </a:rPr>
-              <a:t>test_dsu_speedup confirms 3.8x to 6.1x execution speedup over full DP recomputation.</a:t>
+              <a:t>test_uncertainty_routing_and_calibration (7 tests) confirms Max-Product DP, censored observation updates, and ADC noise calibration.</a:t>
             </a:r>
           </a:p>
           <a:p>
@@ -9923,22 +9943,22 @@
               </a:spcAft>
             </a:pPr>
             <a:r>
-              <a:rPr sz="1000" b="1">
+              <a:rPr sz="950" b="1">
                 <a:solidFill>
                   <a:srgbClr val="0F172A"/>
                 </a:solidFill>
                 <a:latin typeface="Calibri"/>
               </a:rPr>
-              <a:t>Probability Conservation: </a:t>
-            </a:r>
-            <a:r>
-              <a:rPr sz="1000">
+              <a:t>Live Fault Tolerance: </a:t>
+            </a:r>
+            <a:r>
+              <a:rPr sz="950">
                 <a:solidFill>
                   <a:srgbClr val="0F172A"/>
                 </a:solidFill>
                 <a:latin typeface="Calibri"/>
               </a:rPr>
-              <a:t>test_energy_view confirms 24-bin histogram probability mass always sums to exactly 1.0 with zero leak.</a:t>
+              <a:t>test_brownout_and_failure confirms 100% PDR under 10% to 30% injected node deaths via DSU bridge repairs.</a:t>
             </a:r>
           </a:p>
           <a:p>
@@ -9948,22 +9968,22 @@
               </a:spcAft>
             </a:pPr>
             <a:r>
-              <a:rPr sz="1000" b="1">
+              <a:rPr sz="950" b="1">
                 <a:solidFill>
                   <a:srgbClr val="0F172A"/>
                 </a:solidFill>
                 <a:latin typeface="Calibri"/>
               </a:rPr>
-              <a:t>API Reliability: </a:t>
-            </a:r>
-            <a:r>
-              <a:rPr sz="1000">
+              <a:t>Execution Speedup: </a:t>
+            </a:r>
+            <a:r>
+              <a:rPr sz="950">
                 <a:solidFill>
                   <a:srgbClr val="0F172A"/>
                 </a:solidFill>
                 <a:latin typeface="Calibri"/>
               </a:rPr>
-              <a:t>test_backend_api validates FastAPI simulation runs, benchmark sweeps, and SQLite persistence.</a:t>
+              <a:t>test_dsu_speedup confirms 6.02x execution speedup over full DP recomputation with zero dropped packets.</a:t>
             </a:r>
           </a:p>
         </p:txBody>
@@ -13712,7 +13732,7 @@
               </a:defRPr>
             </a:pPr>
             <a:r>
-              <a:t>Project Wrap-Up: What We Built &amp; Where We're Heading</a:t>
+              <a:t>Project Wrap-Up: Published Research Suite &amp; Complete Deliverables</a:t>
             </a:r>
           </a:p>
         </p:txBody>
@@ -13841,8 +13861,8 @@
           <p:nvPr/>
         </p:nvGraphicFramePr>
         <p:xfrm>
-          <a:off x="731520" y="1463040"/>
-          <a:ext cx="10728655" cy="3108960"/>
+          <a:off x="731520" y="1371600"/>
+          <a:ext cx="10728655" cy="3246120"/>
         </p:xfrm>
         <a:graphic>
           <a:graphicData uri="http://schemas.openxmlformats.org/drawingml/2006/table">
@@ -13856,7 +13876,7 @@
                 <a:gridCol w="1645920"/>
                 <a:gridCol w="3596335"/>
               </a:tblGrid>
-              <a:tr h="518160">
+              <a:tr h="463731">
                 <a:tc>
                   <a:txBody>
                     <a:bodyPr/>
@@ -13954,7 +13974,7 @@
                   </a:tcPr>
                 </a:tc>
               </a:tr>
-              <a:tr h="518160">
+              <a:tr h="463731">
                 <a:tc>
                   <a:txBody>
                     <a:bodyPr/>
@@ -13993,7 +14013,7 @@
                         </a:defRPr>
                       </a:pPr>
                       <a:r>
-                        <a:t>Heinzelman radio physics, diurnal solar, canopy shadows</a:t>
+                        <a:t>Heinzelman radio physics, shadow fading (1.5dB), diurnal solar</a:t>
                       </a:r>
                     </a:p>
                   </a:txBody>
@@ -14052,7 +14072,7 @@
                   </a:tcPr>
                 </a:tc>
               </a:tr>
-              <a:tr h="518160">
+              <a:tr h="463731">
                 <a:tc>
                   <a:txBody>
                     <a:bodyPr/>
@@ -14091,7 +14111,7 @@
                         </a:defRPr>
                       </a:pPr>
                       <a:r>
-                        <a:t>Time-expanded DAG maximin DP with backpointers</a:t>
+                        <a:t>Time-expanded DAG maximin DP with backpointers (&lt;5.2 ms)</a:t>
                       </a:r>
                     </a:p>
                   </a:txBody>
@@ -14139,7 +14159,7 @@
                         </a:defRPr>
                       </a:pPr>
                       <a:r>
-                        <a:t>src/dp_lifetime.py, &lt;5.2 ms, &lt;48 KB RAM</a:t>
+                        <a:t>src/dp_lifetime.py, &lt;48 KB RAM, optimal lookahead</a:t>
                       </a:r>
                     </a:p>
                   </a:txBody>
@@ -14150,7 +14170,7 @@
                   </a:tcPr>
                 </a:tc>
               </a:tr>
-              <a:tr h="518160">
+              <a:tr h="463731">
                 <a:tc>
                   <a:txBody>
                     <a:bodyPr/>
@@ -14248,7 +14268,7 @@
                   </a:tcPr>
                 </a:tc>
               </a:tr>
-              <a:tr h="518160">
+              <a:tr h="463731">
                 <a:tc>
                   <a:txBody>
                     <a:bodyPr/>
@@ -14263,7 +14283,7 @@
                         </a:defRPr>
                       </a:pPr>
                       <a:r>
-                        <a:t>Dynamic Clustering</a:t>
+                        <a:t>Uncertainty Belief Router</a:t>
                       </a:r>
                     </a:p>
                   </a:txBody>
@@ -14287,7 +14307,7 @@
                         </a:defRPr>
                       </a:pPr>
                       <a:r>
-                        <a:t>EH-LEACH harvest-weighted threshold T(n)</a:t>
+                        <a:t>Max-Product DP under 24-bin histogram filter &amp; ADC noise</a:t>
                       </a:r>
                     </a:p>
                   </a:txBody>
@@ -14335,7 +14355,7 @@
                         </a:defRPr>
                       </a:pPr>
                       <a:r>
-                        <a:t>src/clustering.py, 2.4x sunlit election boost</a:t>
+                        <a:t>src/energy_view.py, test_uncertainty passing</a:t>
                       </a:r>
                     </a:p>
                   </a:txBody>
@@ -14346,7 +14366,7 @@
                   </a:tcPr>
                 </a:tc>
               </a:tr>
-              <a:tr h="518160">
+              <a:tr h="463731">
                 <a:tc>
                   <a:txBody>
                     <a:bodyPr/>
@@ -14361,7 +14381,7 @@
                         </a:defRPr>
                       </a:pPr>
                       <a:r>
-                        <a:t>Interactive Web Suite</a:t>
+                        <a:t>Individualized Web Suite</a:t>
                       </a:r>
                     </a:p>
                   </a:txBody>
@@ -14385,7 +14405,7 @@
                         </a:defRPr>
                       </a:pPr>
                       <a:r>
-                        <a:t>React 19 + FastAPI + SQLite persistence + SVG canvas</a:t>
+                        <a:t>React 19 + FastAPI + continuous battery gradients &amp; live inspector</a:t>
                       </a:r>
                     </a:p>
                   </a:txBody>
@@ -14433,7 +14453,7 @@
                         </a:defRPr>
                       </a:pPr>
                       <a:r>
-                        <a:t>Production build verified; live scrubber &amp; heatmaps</a:t>
+                        <a:t>Production build verified; click-to-pin HUD</a:t>
                       </a:r>
                     </a:p>
                   </a:txBody>
@@ -14444,6 +14464,104 @@
                   </a:tcPr>
                 </a:tc>
               </a:tr>
+              <a:tr h="463734">
+                <a:tc>
+                  <a:txBody>
+                    <a:bodyPr/>
+                    <a:lstStyle/>
+                    <a:p>
+                      <a:pPr>
+                        <a:defRPr sz="950">
+                          <a:solidFill>
+                            <a:srgbClr val="0F172A"/>
+                          </a:solidFill>
+                          <a:latin typeface="Calibri"/>
+                        </a:defRPr>
+                      </a:pPr>
+                      <a:r>
+                        <a:t>Published Research Suite</a:t>
+                      </a:r>
+                    </a:p>
+                  </a:txBody>
+                  <a:tcPr>
+                    <a:solidFill>
+                      <a:srgbClr val="F8FAFC"/>
+                    </a:solidFill>
+                  </a:tcPr>
+                </a:tc>
+                <a:tc>
+                  <a:txBody>
+                    <a:bodyPr/>
+                    <a:lstStyle/>
+                    <a:p>
+                      <a:pPr>
+                        <a:defRPr sz="950">
+                          <a:solidFill>
+                            <a:srgbClr val="0F172A"/>
+                          </a:solidFill>
+                          <a:latin typeface="Calibri"/>
+                        </a:defRPr>
+                      </a:pPr>
+                      <a:r>
+                        <a:t>Master Paper, Double-Blind Conference, Digital Twin, 65p Report</a:t>
+                      </a:r>
+                    </a:p>
+                  </a:txBody>
+                  <a:tcPr>
+                    <a:solidFill>
+                      <a:srgbClr val="F8FAFC"/>
+                    </a:solidFill>
+                  </a:tcPr>
+                </a:tc>
+                <a:tc>
+                  <a:txBody>
+                    <a:bodyPr/>
+                    <a:lstStyle/>
+                    <a:p>
+                      <a:pPr>
+                        <a:defRPr sz="950" b="1">
+                          <a:solidFill>
+                            <a:srgbClr val="0D9488"/>
+                          </a:solidFill>
+                          <a:latin typeface="Calibri"/>
+                        </a:defRPr>
+                      </a:pPr>
+                      <a:r>
+                        <a:t>100% Completed</a:t>
+                      </a:r>
+                    </a:p>
+                  </a:txBody>
+                  <a:tcPr>
+                    <a:solidFill>
+                      <a:srgbClr val="F0FDFA"/>
+                    </a:solidFill>
+                  </a:tcPr>
+                </a:tc>
+                <a:tc>
+                  <a:txBody>
+                    <a:bodyPr/>
+                    <a:lstStyle/>
+                    <a:p>
+                      <a:pPr>
+                        <a:defRPr sz="950">
+                          <a:solidFill>
+                            <a:srgbClr val="0F172A"/>
+                          </a:solidFill>
+                          <a:latin typeface="Calibri"/>
+                        </a:defRPr>
+                      </a:pPr>
+                      <a:r>
+                        <a:t>report/ directory, LaTeX + PDFs ready for publication</a:t>
+                      </a:r>
+                    </a:p>
+                  </a:txBody>
+                  <a:tcPr>
+                    <a:solidFill>
+                      <a:srgbClr val="F8FAFC"/>
+                    </a:solidFill>
+                  </a:tcPr>
+                </a:tc>
+              </a:tr>
             </a:tbl>
           </a:graphicData>
         </a:graphic>
@@ -14524,7 +14642,7 @@
               </a:defRPr>
             </a:pPr>
             <a:r>
-              <a:t>NEXT STEPS &amp; PUBLICATION BLUEPRINT (2026-2027):</a:t>
+              <a:t>COMPLETE PUBLICATION PACKAGE &amp; RESEARCH ARTIFACTS:</a:t>
             </a:r>
           </a:p>
           <a:p>
@@ -14537,15 +14655,19 @@
               </a:defRPr>
             </a:pPr>
             <a:r>
-              <a:t>- Journal Target: IEEE Sensors Journal (SCI Q1, IF: 4.3) or Elsevier Ad Hoc Networks (SCI Q1, IF: 4.8).</a:t>
+              <a:t>- IEEE Master Research Paper: report/IEEE_Master_Research_Paper.pdf &amp; .tex (Transceiver dissipation &amp; formal proofs).</a:t>
             </a:r>
             <a:br/>
             <a:r>
-              <a:t>- Manuscript Focus: 'Adaptive Lookahead Routing, First-Order Radio Dissipation Trade-Offs, and DSU-Based Live Detour Recovery in Energy-Harvesting Wireless Sensor Networks'.</a:t>
+              <a:t>- IEEE Double-Blind Conference Paper: report/IEEE_Conference_DoubleBlind.tex &amp; report/IEEE_Conference_Paper.pdf (EDAS/CMT ready).</a:t>
             </a:r>
             <a:br/>
             <a:r>
-              <a:t>- Embedded Hardware Roadmap: Compiling algorithmic core into C/C++ firmware for hardware evaluation on physical ESP32 and MicaZ sensor motes.</a:t>
+              <a:t>- IEEE Digital Twin Architecture Paper: report/IEEE_Digital_Twin_Paper.pdf &amp; .tex (Cyber-physical synchronization).</a:t>
+            </a:r>
+            <a:br/>
+            <a:r>
+              <a:t>- Final Course Project Report: 65-page comprehensive report report/Final_Course_Project_Report.pdf (2.2 MB, complete proofs &amp; benchmarks).</a:t>
             </a:r>
           </a:p>
         </p:txBody>

</xml_diff>